<commit_message>
docs: presentacion EP4 con capturas de AWS
</commit_message>
<xml_diff>
--- a/docs/presentacion/EcoPunto-EP4.pptx
+++ b/docs/presentacion/EcoPunto-EP4.pptx
@@ -120,19 +120,19 @@
   <p:extLst>
     <p:ext uri="{521415D9-36F7-43E2-AB2F-B90AF26B5E84}">
       <p14:sectionLst xmlns:p14="http://schemas.microsoft.com/office/powerpoint/2010/main">
-        <p14:section name="Inicio" id="{24becc4b-0f92-6fb6-0e2d-e6a57a676ce1}">
+        <p14:section name="Inicio" id="{dad3d929-ea72-93b9-985f-7677ed6760cc}">
           <p14:sldIdLst>
             <p14:sldId id="256"/>
           </p14:sldIdLst>
         </p14:section>
-        <p14:section name="Solución" id="{7a9bb470-8b92-3341-900b-46242ba65856}">
+        <p14:section name="Solución" id="{69eca917-3250-f189-f54f-c507e7d5e069}">
           <p14:sldIdLst>
             <p14:sldId id="257"/>
             <p14:sldId id="258"/>
             <p14:sldId id="259"/>
           </p14:sldIdLst>
         </p14:section>
-        <p14:section name="Mensajería" id="{bf5cb707-23e0-3f9c-8a70-3d0c01c75fe3}">
+        <p14:section name="Mensajería" id="{44f297c6-b98f-bb05-4010-bf6403234e26}">
           <p14:sldIdLst>
             <p14:sldId id="260"/>
             <p14:sldId id="261"/>
@@ -141,7 +141,7 @@
             <p14:sldId id="264"/>
           </p14:sldIdLst>
         </p14:section>
-        <p14:section name="Evidencia" id="{8309c464-dfc1-9898-ce8a-15f1c494bbf4}">
+        <p14:section name="Evidencia" id="{eedbc08b-d16b-97d7-9fd2-f96025588a55}">
           <p14:sldIdLst>
             <p14:sldId id="265"/>
             <p14:sldId id="266"/>
@@ -739,7 +739,7 @@
             <a:r>
               <a:rPr lang="en-US" dirty="0"/>
               <a:t>(≈20 s · diapositiva de respaldo)
-Estas capturas son del Management UI del clúster. A la izquierda, las seis colas de tipo quorum repartidas entre los dos nodos, con su dead-letter exchange y routing key. A la derecha, un mensaje inválido que terminó en la DLQ de tickets, con el header x-death que indica de qué cola vino y por qué fue rechazado.
+Las capturas de la izquierda son del Management UI del clúster en AWS: arriba los dos nodos y abajo las seis colas de tipo quorum repartidas entre los dos nodos, con su dead-letter exchange y routing key. A la derecha, de la prueba local con el mismo docker compose, un mensaje inválido que terminó en la DLQ de tickets, con el header x-death que indica de qué cola vino y por qué fue rechazado.
 Si algo falla en la demo en vivo, esta es la evidencia.</a:t>
             </a:r>
             <a:endParaRPr lang="en-US" dirty="0"/>
@@ -4953,7 +4953,7 @@
                 <a:ea typeface="Calibri" pitchFamily="34" charset="-122"/>
                 <a:cs typeface="Calibri" pitchFamily="34" charset="-120"/>
               </a:rPr>
-              <a:t>Clúster: los dos nodos en ejecución</a:t>
+              <a:t>AWS · los dos nodos del clúster en ejecución</a:t>
             </a:r>
             <a:endParaRPr lang="en-US" sz="1200" dirty="0"/>
           </a:p>
@@ -5016,7 +5016,7 @@
                 <a:ea typeface="Calibri" pitchFamily="34" charset="-122"/>
                 <a:cs typeface="Calibri" pitchFamily="34" charset="-120"/>
               </a:rPr>
-              <a:t>6 colas quorum, cada una con su DLX y DLK</a:t>
+              <a:t>AWS · 6 colas quorum, cada una con su DLX y DLK</a:t>
             </a:r>
             <a:endParaRPr lang="en-US" sz="1200" dirty="0"/>
           </a:p>
@@ -5113,7 +5113,7 @@
                 <a:ea typeface="Calibri" pitchFamily="34" charset="-122"/>
                 <a:cs typeface="Calibri" pitchFamily="34" charset="-120"/>
               </a:rPr>
-              <a:t>Mensaje inválido en la DLQ (x-death)</a:t>
+              <a:t>Prueba local · mensaje inválido en la DLQ</a:t>
             </a:r>
             <a:endParaRPr lang="en-US" sz="1200" dirty="0"/>
           </a:p>

</xml_diff>

<commit_message>
docs: captura de la DLQ en AWS
</commit_message>
<xml_diff>
--- a/docs/presentacion/EcoPunto-EP4.pptx
+++ b/docs/presentacion/EcoPunto-EP4.pptx
@@ -120,19 +120,19 @@
   <p:extLst>
     <p:ext uri="{521415D9-36F7-43E2-AB2F-B90AF26B5E84}">
       <p14:sectionLst xmlns:p14="http://schemas.microsoft.com/office/powerpoint/2010/main">
-        <p14:section name="Inicio" id="{dad3d929-ea72-93b9-985f-7677ed6760cc}">
+        <p14:section name="Inicio" id="{2ae29a3c-a73a-3651-0db7-74526c962535}">
           <p14:sldIdLst>
             <p14:sldId id="256"/>
           </p14:sldIdLst>
         </p14:section>
-        <p14:section name="Solución" id="{69eca917-3250-f189-f54f-c507e7d5e069}">
+        <p14:section name="Solución" id="{d12c78df-f7ba-c3f8-17c7-89db409ca036}">
           <p14:sldIdLst>
             <p14:sldId id="257"/>
             <p14:sldId id="258"/>
             <p14:sldId id="259"/>
           </p14:sldIdLst>
         </p14:section>
-        <p14:section name="Mensajería" id="{44f297c6-b98f-bb05-4010-bf6403234e26}">
+        <p14:section name="Mensajería" id="{5abb7967-4510-a5d9-3fde-f33eb0d7cb39}">
           <p14:sldIdLst>
             <p14:sldId id="260"/>
             <p14:sldId id="261"/>
@@ -141,7 +141,7 @@
             <p14:sldId id="264"/>
           </p14:sldIdLst>
         </p14:section>
-        <p14:section name="Evidencia" id="{eedbc08b-d16b-97d7-9fd2-f96025588a55}">
+        <p14:section name="Evidencia" id="{98194b95-d40f-5b9a-b2b3-de540df6e5f9}">
           <p14:sldIdLst>
             <p14:sldId id="265"/>
             <p14:sldId id="266"/>
@@ -739,7 +739,7 @@
             <a:r>
               <a:rPr lang="en-US" dirty="0"/>
               <a:t>(≈20 s · diapositiva de respaldo)
-Las capturas de la izquierda son del Management UI del clúster en AWS: arriba los dos nodos y abajo las seis colas de tipo quorum repartidas entre los dos nodos, con su dead-letter exchange y routing key. A la derecha, de la prueba local con el mismo docker compose, un mensaje inválido que terminó en la DLQ de tickets, con el header x-death que indica de qué cola vino y por qué fue rechazado.
+Estas capturas son del Management UI del clúster en AWS. A la izquierda, arriba los dos nodos y abajo las seis colas de tipo quorum repartidas entre los dos nodos, con su dead-letter exchange y routing key. A la derecha, un mensaje inválido que terminó en la DLQ de tickets, con el header x-death que indica de qué cola vino y por qué fue rechazado.
 Si algo falla en la demo en vivo, esta es la evidencia.</a:t>
             </a:r>
             <a:endParaRPr lang="en-US" dirty="0"/>
@@ -4880,7 +4880,7 @@
                 <a:ea typeface="Calibri" pitchFamily="34" charset="-122"/>
                 <a:cs typeface="Calibri" pitchFamily="34" charset="-120"/>
               </a:rPr>
-              <a:t>Evidencia: Management UI de RabbitMQ</a:t>
+              <a:t>Evidencia: RabbitMQ en la nube</a:t>
             </a:r>
             <a:endParaRPr lang="en-US" sz="3000" dirty="0"/>
           </a:p>
@@ -5113,7 +5113,7 @@
                 <a:ea typeface="Calibri" pitchFamily="34" charset="-122"/>
                 <a:cs typeface="Calibri" pitchFamily="34" charset="-120"/>
               </a:rPr>
-              <a:t>Prueba local · mensaje inválido en la DLQ</a:t>
+              <a:t>AWS · mensaje inválido en la DLQ (x-death)</a:t>
             </a:r>
             <a:endParaRPr lang="en-US" sz="1200" dirty="0"/>
           </a:p>

</xml_diff>